<commit_message>
Fix/profile tutorial media hardening (#25)
* WIP: mes modifications

* Harden profile and tutorial media flows
</commit_message>
<xml_diff>
--- a/presentation_sprint_review_stories.pptx
+++ b/presentation_sprint_review_stories.pptx
@@ -5,20 +5,20 @@
     <p:sldMasterId id="2147483648" r:id="rId1"/>
   </p:sldMasterIdLst>
   <p:sldIdLst>
-    <p:sldId id="256" r:id="rId7"/>
-    <p:sldId id="257" r:id="rId8"/>
-    <p:sldId id="258" r:id="rId9"/>
-    <p:sldId id="259" r:id="rId10"/>
-    <p:sldId id="260" r:id="rId11"/>
-    <p:sldId id="261" r:id="rId12"/>
-    <p:sldId id="262" r:id="rId13"/>
-    <p:sldId id="263" r:id="rId14"/>
-    <p:sldId id="264" r:id="rId15"/>
-    <p:sldId id="265" r:id="rId16"/>
-    <p:sldId id="266" r:id="rId17"/>
-    <p:sldId id="267" r:id="rId18"/>
+    <p:sldId id="256" r:id="rId2"/>
+    <p:sldId id="257" r:id="rId3"/>
+    <p:sldId id="258" r:id="rId4"/>
+    <p:sldId id="259" r:id="rId5"/>
+    <p:sldId id="260" r:id="rId6"/>
+    <p:sldId id="261" r:id="rId7"/>
+    <p:sldId id="262" r:id="rId8"/>
+    <p:sldId id="263" r:id="rId9"/>
+    <p:sldId id="264" r:id="rId10"/>
+    <p:sldId id="265" r:id="rId11"/>
+    <p:sldId id="266" r:id="rId12"/>
+    <p:sldId id="267" r:id="rId13"/>
   </p:sldIdLst>
-  <p:sldSz cx="12191695" cy="6858000" type="screen4x3"/>
+  <p:sldSz cx="12192000" cy="6858000"/>
   <p:notesSz cx="6858000" cy="9144000"/>
   <p:defaultTextStyle>
     <a:defPPr>
@@ -115,6 +115,22 @@
       </a:defRPr>
     </a:lvl9pPr>
   </p:defaultTextStyle>
+  <p:extLst>
+    <p:ext uri="{EFAFB233-063F-42B5-8137-9DF3F51BA10A}">
+      <p15:sldGuideLst xmlns:p15="http://schemas.microsoft.com/office/powerpoint/2012/main">
+        <p15:guide id="1" orient="horz" pos="2160">
+          <p15:clr>
+            <a:srgbClr val="A4A3A4"/>
+          </p15:clr>
+        </p15:guide>
+        <p15:guide id="2" pos="2880">
+          <p15:clr>
+            <a:srgbClr val="A4A3A4"/>
+          </p15:clr>
+        </p15:guide>
+      </p15:sldGuideLst>
+    </p:ext>
+  </p:extLst>
 </p:presentation>
 </file>
 
@@ -156,10 +172,9 @@
           <a:lstStyle/>
           <a:p>
             <a:r>
-              <a:rPr lang="en-US" smtClean="0"/>
+              <a:rPr lang="en-US"/>
               <a:t>Click to edit Master title style</a:t>
             </a:r>
-            <a:endParaRPr lang="en-US"/>
           </a:p>
         </p:txBody>
       </p:sp>
@@ -275,10 +290,9 @@
           </a:lstStyle>
           <a:p>
             <a:r>
-              <a:rPr lang="en-US" smtClean="0"/>
+              <a:rPr lang="en-US"/>
               <a:t>Click to edit Master subtitle style</a:t>
             </a:r>
-            <a:endParaRPr lang="en-US"/>
           </a:p>
         </p:txBody>
       </p:sp>
@@ -299,7 +313,7 @@
           <a:p>
             <a:fld id="{5BCAD085-E8A6-8845-BD4E-CB4CCA059FC4}" type="datetimeFigureOut">
               <a:rPr lang="en-US" smtClean="0"/>
-              <a:t>1/27/13</a:t>
+              <a:t>3/24/2026</a:t>
             </a:fld>
             <a:endParaRPr lang="en-US"/>
           </a:p>
@@ -341,7 +355,7 @@
           <a:p>
             <a:fld id="{C1FF6DA9-008F-8B48-92A6-B652298478BF}" type="slidenum">
               <a:rPr lang="en-US" smtClean="0"/>
-              <a:t>‹#›</a:t>
+              <a:t>‹N°›</a:t>
             </a:fld>
             <a:endParaRPr lang="en-US"/>
           </a:p>
@@ -393,10 +407,9 @@
           <a:lstStyle/>
           <a:p>
             <a:r>
-              <a:rPr lang="en-US" smtClean="0"/>
+              <a:rPr lang="en-US"/>
               <a:t>Click to edit Master title style</a:t>
             </a:r>
-            <a:endParaRPr lang="en-US"/>
           </a:p>
         </p:txBody>
       </p:sp>
@@ -417,38 +430,37 @@
           <a:p>
             <a:pPr lvl="0"/>
             <a:r>
-              <a:rPr lang="en-US" smtClean="0"/>
+              <a:rPr lang="en-US"/>
               <a:t>Click to edit Master text styles</a:t>
             </a:r>
           </a:p>
           <a:p>
             <a:pPr lvl="1"/>
             <a:r>
-              <a:rPr lang="en-US" smtClean="0"/>
+              <a:rPr lang="en-US"/>
               <a:t>Second level</a:t>
             </a:r>
           </a:p>
           <a:p>
             <a:pPr lvl="2"/>
             <a:r>
-              <a:rPr lang="en-US" smtClean="0"/>
+              <a:rPr lang="en-US"/>
               <a:t>Third level</a:t>
             </a:r>
           </a:p>
           <a:p>
             <a:pPr lvl="3"/>
             <a:r>
-              <a:rPr lang="en-US" smtClean="0"/>
+              <a:rPr lang="en-US"/>
               <a:t>Fourth level</a:t>
             </a:r>
           </a:p>
           <a:p>
             <a:pPr lvl="4"/>
             <a:r>
-              <a:rPr lang="en-US" smtClean="0"/>
+              <a:rPr lang="en-US"/>
               <a:t>Fifth level</a:t>
             </a:r>
-            <a:endParaRPr lang="en-US"/>
           </a:p>
         </p:txBody>
       </p:sp>
@@ -469,7 +481,7 @@
           <a:p>
             <a:fld id="{5BCAD085-E8A6-8845-BD4E-CB4CCA059FC4}" type="datetimeFigureOut">
               <a:rPr lang="en-US" smtClean="0"/>
-              <a:t>1/27/13</a:t>
+              <a:t>3/24/2026</a:t>
             </a:fld>
             <a:endParaRPr lang="en-US"/>
           </a:p>
@@ -511,7 +523,7 @@
           <a:p>
             <a:fld id="{C1FF6DA9-008F-8B48-92A6-B652298478BF}" type="slidenum">
               <a:rPr lang="en-US" smtClean="0"/>
-              <a:t>‹#›</a:t>
+              <a:t>‹N°›</a:t>
             </a:fld>
             <a:endParaRPr lang="en-US"/>
           </a:p>
@@ -568,10 +580,9 @@
           <a:lstStyle/>
           <a:p>
             <a:r>
-              <a:rPr lang="en-US" smtClean="0"/>
+              <a:rPr lang="en-US"/>
               <a:t>Click to edit Master title style</a:t>
             </a:r>
-            <a:endParaRPr lang="en-US"/>
           </a:p>
         </p:txBody>
       </p:sp>
@@ -597,38 +608,37 @@
           <a:p>
             <a:pPr lvl="0"/>
             <a:r>
-              <a:rPr lang="en-US" smtClean="0"/>
+              <a:rPr lang="en-US"/>
               <a:t>Click to edit Master text styles</a:t>
             </a:r>
           </a:p>
           <a:p>
             <a:pPr lvl="1"/>
             <a:r>
-              <a:rPr lang="en-US" smtClean="0"/>
+              <a:rPr lang="en-US"/>
               <a:t>Second level</a:t>
             </a:r>
           </a:p>
           <a:p>
             <a:pPr lvl="2"/>
             <a:r>
-              <a:rPr lang="en-US" smtClean="0"/>
+              <a:rPr lang="en-US"/>
               <a:t>Third level</a:t>
             </a:r>
           </a:p>
           <a:p>
             <a:pPr lvl="3"/>
             <a:r>
-              <a:rPr lang="en-US" smtClean="0"/>
+              <a:rPr lang="en-US"/>
               <a:t>Fourth level</a:t>
             </a:r>
           </a:p>
           <a:p>
             <a:pPr lvl="4"/>
             <a:r>
-              <a:rPr lang="en-US" smtClean="0"/>
+              <a:rPr lang="en-US"/>
               <a:t>Fifth level</a:t>
             </a:r>
-            <a:endParaRPr lang="en-US"/>
           </a:p>
         </p:txBody>
       </p:sp>
@@ -649,7 +659,7 @@
           <a:p>
             <a:fld id="{5BCAD085-E8A6-8845-BD4E-CB4CCA059FC4}" type="datetimeFigureOut">
               <a:rPr lang="en-US" smtClean="0"/>
-              <a:t>1/27/13</a:t>
+              <a:t>3/24/2026</a:t>
             </a:fld>
             <a:endParaRPr lang="en-US"/>
           </a:p>
@@ -691,7 +701,7 @@
           <a:p>
             <a:fld id="{C1FF6DA9-008F-8B48-92A6-B652298478BF}" type="slidenum">
               <a:rPr lang="en-US" smtClean="0"/>
-              <a:t>‹#›</a:t>
+              <a:t>‹N°›</a:t>
             </a:fld>
             <a:endParaRPr lang="en-US"/>
           </a:p>
@@ -743,10 +753,9 @@
           <a:lstStyle/>
           <a:p>
             <a:r>
-              <a:rPr lang="en-US" smtClean="0"/>
+              <a:rPr lang="en-US"/>
               <a:t>Click to edit Master title style</a:t>
             </a:r>
-            <a:endParaRPr lang="en-US"/>
           </a:p>
         </p:txBody>
       </p:sp>
@@ -767,38 +776,37 @@
           <a:p>
             <a:pPr lvl="0"/>
             <a:r>
-              <a:rPr lang="en-US" smtClean="0"/>
+              <a:rPr lang="en-US"/>
               <a:t>Click to edit Master text styles</a:t>
             </a:r>
           </a:p>
           <a:p>
             <a:pPr lvl="1"/>
             <a:r>
-              <a:rPr lang="en-US" smtClean="0"/>
+              <a:rPr lang="en-US"/>
               <a:t>Second level</a:t>
             </a:r>
           </a:p>
           <a:p>
             <a:pPr lvl="2"/>
             <a:r>
-              <a:rPr lang="en-US" smtClean="0"/>
+              <a:rPr lang="en-US"/>
               <a:t>Third level</a:t>
             </a:r>
           </a:p>
           <a:p>
             <a:pPr lvl="3"/>
             <a:r>
-              <a:rPr lang="en-US" smtClean="0"/>
+              <a:rPr lang="en-US"/>
               <a:t>Fourth level</a:t>
             </a:r>
           </a:p>
           <a:p>
             <a:pPr lvl="4"/>
             <a:r>
-              <a:rPr lang="en-US" smtClean="0"/>
+              <a:rPr lang="en-US"/>
               <a:t>Fifth level</a:t>
             </a:r>
-            <a:endParaRPr lang="en-US"/>
           </a:p>
         </p:txBody>
       </p:sp>
@@ -819,7 +827,7 @@
           <a:p>
             <a:fld id="{5BCAD085-E8A6-8845-BD4E-CB4CCA059FC4}" type="datetimeFigureOut">
               <a:rPr lang="en-US" smtClean="0"/>
-              <a:t>1/27/13</a:t>
+              <a:t>3/24/2026</a:t>
             </a:fld>
             <a:endParaRPr lang="en-US"/>
           </a:p>
@@ -861,7 +869,7 @@
           <a:p>
             <a:fld id="{C1FF6DA9-008F-8B48-92A6-B652298478BF}" type="slidenum">
               <a:rPr lang="en-US" smtClean="0"/>
-              <a:t>‹#›</a:t>
+              <a:t>‹N°›</a:t>
             </a:fld>
             <a:endParaRPr lang="en-US"/>
           </a:p>
@@ -922,10 +930,9 @@
           </a:lstStyle>
           <a:p>
             <a:r>
-              <a:rPr lang="en-US" smtClean="0"/>
+              <a:rPr lang="en-US"/>
               <a:t>Click to edit Master title style</a:t>
             </a:r>
-            <a:endParaRPr lang="en-US"/>
           </a:p>
         </p:txBody>
       </p:sp>
@@ -1042,7 +1049,7 @@
           <a:p>
             <a:pPr lvl="0"/>
             <a:r>
-              <a:rPr lang="en-US" smtClean="0"/>
+              <a:rPr lang="en-US"/>
               <a:t>Click to edit Master text styles</a:t>
             </a:r>
           </a:p>
@@ -1065,7 +1072,7 @@
           <a:p>
             <a:fld id="{5BCAD085-E8A6-8845-BD4E-CB4CCA059FC4}" type="datetimeFigureOut">
               <a:rPr lang="en-US" smtClean="0"/>
-              <a:t>1/27/13</a:t>
+              <a:t>3/24/2026</a:t>
             </a:fld>
             <a:endParaRPr lang="en-US"/>
           </a:p>
@@ -1107,7 +1114,7 @@
           <a:p>
             <a:fld id="{C1FF6DA9-008F-8B48-92A6-B652298478BF}" type="slidenum">
               <a:rPr lang="en-US" smtClean="0"/>
-              <a:t>‹#›</a:t>
+              <a:t>‹N°›</a:t>
             </a:fld>
             <a:endParaRPr lang="en-US"/>
           </a:p>
@@ -1159,10 +1166,9 @@
           <a:lstStyle/>
           <a:p>
             <a:r>
-              <a:rPr lang="en-US" smtClean="0"/>
+              <a:rPr lang="en-US"/>
               <a:t>Click to edit Master title style</a:t>
             </a:r>
-            <a:endParaRPr lang="en-US"/>
           </a:p>
         </p:txBody>
       </p:sp>
@@ -1216,38 +1222,37 @@
           <a:p>
             <a:pPr lvl="0"/>
             <a:r>
-              <a:rPr lang="en-US" smtClean="0"/>
+              <a:rPr lang="en-US"/>
               <a:t>Click to edit Master text styles</a:t>
             </a:r>
           </a:p>
           <a:p>
             <a:pPr lvl="1"/>
             <a:r>
-              <a:rPr lang="en-US" smtClean="0"/>
+              <a:rPr lang="en-US"/>
               <a:t>Second level</a:t>
             </a:r>
           </a:p>
           <a:p>
             <a:pPr lvl="2"/>
             <a:r>
-              <a:rPr lang="en-US" smtClean="0"/>
+              <a:rPr lang="en-US"/>
               <a:t>Third level</a:t>
             </a:r>
           </a:p>
           <a:p>
             <a:pPr lvl="3"/>
             <a:r>
-              <a:rPr lang="en-US" smtClean="0"/>
+              <a:rPr lang="en-US"/>
               <a:t>Fourth level</a:t>
             </a:r>
           </a:p>
           <a:p>
             <a:pPr lvl="4"/>
             <a:r>
-              <a:rPr lang="en-US" smtClean="0"/>
+              <a:rPr lang="en-US"/>
               <a:t>Fifth level</a:t>
             </a:r>
-            <a:endParaRPr lang="en-US"/>
           </a:p>
         </p:txBody>
       </p:sp>
@@ -1301,38 +1306,37 @@
           <a:p>
             <a:pPr lvl="0"/>
             <a:r>
-              <a:rPr lang="en-US" smtClean="0"/>
+              <a:rPr lang="en-US"/>
               <a:t>Click to edit Master text styles</a:t>
             </a:r>
           </a:p>
           <a:p>
             <a:pPr lvl="1"/>
             <a:r>
-              <a:rPr lang="en-US" smtClean="0"/>
+              <a:rPr lang="en-US"/>
               <a:t>Second level</a:t>
             </a:r>
           </a:p>
           <a:p>
             <a:pPr lvl="2"/>
             <a:r>
-              <a:rPr lang="en-US" smtClean="0"/>
+              <a:rPr lang="en-US"/>
               <a:t>Third level</a:t>
             </a:r>
           </a:p>
           <a:p>
             <a:pPr lvl="3"/>
             <a:r>
-              <a:rPr lang="en-US" smtClean="0"/>
+              <a:rPr lang="en-US"/>
               <a:t>Fourth level</a:t>
             </a:r>
           </a:p>
           <a:p>
             <a:pPr lvl="4"/>
             <a:r>
-              <a:rPr lang="en-US" smtClean="0"/>
+              <a:rPr lang="en-US"/>
               <a:t>Fifth level</a:t>
             </a:r>
-            <a:endParaRPr lang="en-US"/>
           </a:p>
         </p:txBody>
       </p:sp>
@@ -1353,7 +1357,7 @@
           <a:p>
             <a:fld id="{5BCAD085-E8A6-8845-BD4E-CB4CCA059FC4}" type="datetimeFigureOut">
               <a:rPr lang="en-US" smtClean="0"/>
-              <a:t>1/27/13</a:t>
+              <a:t>3/24/2026</a:t>
             </a:fld>
             <a:endParaRPr lang="en-US"/>
           </a:p>
@@ -1395,7 +1399,7 @@
           <a:p>
             <a:fld id="{C1FF6DA9-008F-8B48-92A6-B652298478BF}" type="slidenum">
               <a:rPr lang="en-US" smtClean="0"/>
-              <a:t>‹#›</a:t>
+              <a:t>‹N°›</a:t>
             </a:fld>
             <a:endParaRPr lang="en-US"/>
           </a:p>
@@ -1451,10 +1455,9 @@
           </a:lstStyle>
           <a:p>
             <a:r>
-              <a:rPr lang="en-US" smtClean="0"/>
+              <a:rPr lang="en-US"/>
               <a:t>Click to edit Master title style</a:t>
             </a:r>
-            <a:endParaRPr lang="en-US"/>
           </a:p>
         </p:txBody>
       </p:sp>
@@ -1517,7 +1520,7 @@
           <a:p>
             <a:pPr lvl="0"/>
             <a:r>
-              <a:rPr lang="en-US" smtClean="0"/>
+              <a:rPr lang="en-US"/>
               <a:t>Click to edit Master text styles</a:t>
             </a:r>
           </a:p>
@@ -1573,38 +1576,37 @@
           <a:p>
             <a:pPr lvl="0"/>
             <a:r>
-              <a:rPr lang="en-US" smtClean="0"/>
+              <a:rPr lang="en-US"/>
               <a:t>Click to edit Master text styles</a:t>
             </a:r>
           </a:p>
           <a:p>
             <a:pPr lvl="1"/>
             <a:r>
-              <a:rPr lang="en-US" smtClean="0"/>
+              <a:rPr lang="en-US"/>
               <a:t>Second level</a:t>
             </a:r>
           </a:p>
           <a:p>
             <a:pPr lvl="2"/>
             <a:r>
-              <a:rPr lang="en-US" smtClean="0"/>
+              <a:rPr lang="en-US"/>
               <a:t>Third level</a:t>
             </a:r>
           </a:p>
           <a:p>
             <a:pPr lvl="3"/>
             <a:r>
-              <a:rPr lang="en-US" smtClean="0"/>
+              <a:rPr lang="en-US"/>
               <a:t>Fourth level</a:t>
             </a:r>
           </a:p>
           <a:p>
             <a:pPr lvl="4"/>
             <a:r>
-              <a:rPr lang="en-US" smtClean="0"/>
+              <a:rPr lang="en-US"/>
               <a:t>Fifth level</a:t>
             </a:r>
-            <a:endParaRPr lang="en-US"/>
           </a:p>
         </p:txBody>
       </p:sp>
@@ -1667,7 +1669,7 @@
           <a:p>
             <a:pPr lvl="0"/>
             <a:r>
-              <a:rPr lang="en-US" smtClean="0"/>
+              <a:rPr lang="en-US"/>
               <a:t>Click to edit Master text styles</a:t>
             </a:r>
           </a:p>
@@ -1723,38 +1725,37 @@
           <a:p>
             <a:pPr lvl="0"/>
             <a:r>
-              <a:rPr lang="en-US" smtClean="0"/>
+              <a:rPr lang="en-US"/>
               <a:t>Click to edit Master text styles</a:t>
             </a:r>
           </a:p>
           <a:p>
             <a:pPr lvl="1"/>
             <a:r>
-              <a:rPr lang="en-US" smtClean="0"/>
+              <a:rPr lang="en-US"/>
               <a:t>Second level</a:t>
             </a:r>
           </a:p>
           <a:p>
             <a:pPr lvl="2"/>
             <a:r>
-              <a:rPr lang="en-US" smtClean="0"/>
+              <a:rPr lang="en-US"/>
               <a:t>Third level</a:t>
             </a:r>
           </a:p>
           <a:p>
             <a:pPr lvl="3"/>
             <a:r>
-              <a:rPr lang="en-US" smtClean="0"/>
+              <a:rPr lang="en-US"/>
               <a:t>Fourth level</a:t>
             </a:r>
           </a:p>
           <a:p>
             <a:pPr lvl="4"/>
             <a:r>
-              <a:rPr lang="en-US" smtClean="0"/>
+              <a:rPr lang="en-US"/>
               <a:t>Fifth level</a:t>
             </a:r>
-            <a:endParaRPr lang="en-US"/>
           </a:p>
         </p:txBody>
       </p:sp>
@@ -1775,7 +1776,7 @@
           <a:p>
             <a:fld id="{5BCAD085-E8A6-8845-BD4E-CB4CCA059FC4}" type="datetimeFigureOut">
               <a:rPr lang="en-US" smtClean="0"/>
-              <a:t>1/27/13</a:t>
+              <a:t>3/24/2026</a:t>
             </a:fld>
             <a:endParaRPr lang="en-US"/>
           </a:p>
@@ -1817,7 +1818,7 @@
           <a:p>
             <a:fld id="{C1FF6DA9-008F-8B48-92A6-B652298478BF}" type="slidenum">
               <a:rPr lang="en-US" smtClean="0"/>
-              <a:t>‹#›</a:t>
+              <a:t>‹N°›</a:t>
             </a:fld>
             <a:endParaRPr lang="en-US"/>
           </a:p>
@@ -1869,10 +1870,9 @@
           <a:lstStyle/>
           <a:p>
             <a:r>
-              <a:rPr lang="en-US" smtClean="0"/>
+              <a:rPr lang="en-US"/>
               <a:t>Click to edit Master title style</a:t>
             </a:r>
-            <a:endParaRPr lang="en-US"/>
           </a:p>
         </p:txBody>
       </p:sp>
@@ -1893,7 +1893,7 @@
           <a:p>
             <a:fld id="{5BCAD085-E8A6-8845-BD4E-CB4CCA059FC4}" type="datetimeFigureOut">
               <a:rPr lang="en-US" smtClean="0"/>
-              <a:t>1/27/13</a:t>
+              <a:t>3/24/2026</a:t>
             </a:fld>
             <a:endParaRPr lang="en-US"/>
           </a:p>
@@ -1935,7 +1935,7 @@
           <a:p>
             <a:fld id="{C1FF6DA9-008F-8B48-92A6-B652298478BF}" type="slidenum">
               <a:rPr lang="en-US" smtClean="0"/>
-              <a:t>‹#›</a:t>
+              <a:t>‹N°›</a:t>
             </a:fld>
             <a:endParaRPr lang="en-US"/>
           </a:p>
@@ -1988,7 +1988,7 @@
           <a:p>
             <a:fld id="{5BCAD085-E8A6-8845-BD4E-CB4CCA059FC4}" type="datetimeFigureOut">
               <a:rPr lang="en-US" smtClean="0"/>
-              <a:t>1/27/13</a:t>
+              <a:t>3/24/2026</a:t>
             </a:fld>
             <a:endParaRPr lang="en-US"/>
           </a:p>
@@ -2030,7 +2030,7 @@
           <a:p>
             <a:fld id="{C1FF6DA9-008F-8B48-92A6-B652298478BF}" type="slidenum">
               <a:rPr lang="en-US" smtClean="0"/>
-              <a:t>‹#›</a:t>
+              <a:t>‹N°›</a:t>
             </a:fld>
             <a:endParaRPr lang="en-US"/>
           </a:p>
@@ -2091,10 +2091,9 @@
           </a:lstStyle>
           <a:p>
             <a:r>
-              <a:rPr lang="en-US" smtClean="0"/>
+              <a:rPr lang="en-US"/>
               <a:t>Click to edit Master title style</a:t>
             </a:r>
-            <a:endParaRPr lang="en-US"/>
           </a:p>
         </p:txBody>
       </p:sp>
@@ -2148,38 +2147,37 @@
           <a:p>
             <a:pPr lvl="0"/>
             <a:r>
-              <a:rPr lang="en-US" smtClean="0"/>
+              <a:rPr lang="en-US"/>
               <a:t>Click to edit Master text styles</a:t>
             </a:r>
           </a:p>
           <a:p>
             <a:pPr lvl="1"/>
             <a:r>
-              <a:rPr lang="en-US" smtClean="0"/>
+              <a:rPr lang="en-US"/>
               <a:t>Second level</a:t>
             </a:r>
           </a:p>
           <a:p>
             <a:pPr lvl="2"/>
             <a:r>
-              <a:rPr lang="en-US" smtClean="0"/>
+              <a:rPr lang="en-US"/>
               <a:t>Third level</a:t>
             </a:r>
           </a:p>
           <a:p>
             <a:pPr lvl="3"/>
             <a:r>
-              <a:rPr lang="en-US" smtClean="0"/>
+              <a:rPr lang="en-US"/>
               <a:t>Fourth level</a:t>
             </a:r>
           </a:p>
           <a:p>
             <a:pPr lvl="4"/>
             <a:r>
-              <a:rPr lang="en-US" smtClean="0"/>
+              <a:rPr lang="en-US"/>
               <a:t>Fifth level</a:t>
             </a:r>
-            <a:endParaRPr lang="en-US"/>
           </a:p>
         </p:txBody>
       </p:sp>
@@ -2242,7 +2240,7 @@
           <a:p>
             <a:pPr lvl="0"/>
             <a:r>
-              <a:rPr lang="en-US" smtClean="0"/>
+              <a:rPr lang="en-US"/>
               <a:t>Click to edit Master text styles</a:t>
             </a:r>
           </a:p>
@@ -2265,7 +2263,7 @@
           <a:p>
             <a:fld id="{5BCAD085-E8A6-8845-BD4E-CB4CCA059FC4}" type="datetimeFigureOut">
               <a:rPr lang="en-US" smtClean="0"/>
-              <a:t>1/27/13</a:t>
+              <a:t>3/24/2026</a:t>
             </a:fld>
             <a:endParaRPr lang="en-US"/>
           </a:p>
@@ -2307,7 +2305,7 @@
           <a:p>
             <a:fld id="{C1FF6DA9-008F-8B48-92A6-B652298478BF}" type="slidenum">
               <a:rPr lang="en-US" smtClean="0"/>
-              <a:t>‹#›</a:t>
+              <a:t>‹N°›</a:t>
             </a:fld>
             <a:endParaRPr lang="en-US"/>
           </a:p>
@@ -2368,10 +2366,9 @@
           </a:lstStyle>
           <a:p>
             <a:r>
-              <a:rPr lang="en-US" smtClean="0"/>
+              <a:rPr lang="en-US"/>
               <a:t>Click to edit Master title style</a:t>
             </a:r>
-            <a:endParaRPr lang="en-US"/>
           </a:p>
         </p:txBody>
       </p:sp>
@@ -2495,7 +2492,7 @@
           <a:p>
             <a:pPr lvl="0"/>
             <a:r>
-              <a:rPr lang="en-US" smtClean="0"/>
+              <a:rPr lang="en-US"/>
               <a:t>Click to edit Master text styles</a:t>
             </a:r>
           </a:p>
@@ -2518,7 +2515,7 @@
           <a:p>
             <a:fld id="{5BCAD085-E8A6-8845-BD4E-CB4CCA059FC4}" type="datetimeFigureOut">
               <a:rPr lang="en-US" smtClean="0"/>
-              <a:t>1/27/13</a:t>
+              <a:t>3/24/2026</a:t>
             </a:fld>
             <a:endParaRPr lang="en-US"/>
           </a:p>
@@ -2560,7 +2557,7 @@
           <a:p>
             <a:fld id="{C1FF6DA9-008F-8B48-92A6-B652298478BF}" type="slidenum">
               <a:rPr lang="en-US" smtClean="0"/>
-              <a:t>‹#›</a:t>
+              <a:t>‹N°›</a:t>
             </a:fld>
             <a:endParaRPr lang="en-US"/>
           </a:p>
@@ -2627,10 +2624,9 @@
           <a:lstStyle/>
           <a:p>
             <a:r>
-              <a:rPr lang="en-US" smtClean="0"/>
+              <a:rPr lang="en-US"/>
               <a:t>Click to edit Master title style</a:t>
             </a:r>
-            <a:endParaRPr lang="en-US"/>
           </a:p>
         </p:txBody>
       </p:sp>
@@ -2661,38 +2657,37 @@
           <a:p>
             <a:pPr lvl="0"/>
             <a:r>
-              <a:rPr lang="en-US" smtClean="0"/>
+              <a:rPr lang="en-US"/>
               <a:t>Click to edit Master text styles</a:t>
             </a:r>
           </a:p>
           <a:p>
             <a:pPr lvl="1"/>
             <a:r>
-              <a:rPr lang="en-US" smtClean="0"/>
+              <a:rPr lang="en-US"/>
               <a:t>Second level</a:t>
             </a:r>
           </a:p>
           <a:p>
             <a:pPr lvl="2"/>
             <a:r>
-              <a:rPr lang="en-US" smtClean="0"/>
+              <a:rPr lang="en-US"/>
               <a:t>Third level</a:t>
             </a:r>
           </a:p>
           <a:p>
             <a:pPr lvl="3"/>
             <a:r>
-              <a:rPr lang="en-US" smtClean="0"/>
+              <a:rPr lang="en-US"/>
               <a:t>Fourth level</a:t>
             </a:r>
           </a:p>
           <a:p>
             <a:pPr lvl="4"/>
             <a:r>
-              <a:rPr lang="en-US" smtClean="0"/>
+              <a:rPr lang="en-US"/>
               <a:t>Fifth level</a:t>
             </a:r>
-            <a:endParaRPr lang="en-US"/>
           </a:p>
         </p:txBody>
       </p:sp>
@@ -2731,7 +2726,7 @@
           <a:p>
             <a:fld id="{5BCAD085-E8A6-8845-BD4E-CB4CCA059FC4}" type="datetimeFigureOut">
               <a:rPr lang="en-US" smtClean="0"/>
-              <a:t>1/27/13</a:t>
+              <a:t>3/24/2026</a:t>
             </a:fld>
             <a:endParaRPr lang="en-US"/>
           </a:p>
@@ -2809,7 +2804,7 @@
           <a:p>
             <a:fld id="{C1FF6DA9-008F-8B48-92A6-B652298478BF}" type="slidenum">
               <a:rPr lang="en-US" smtClean="0"/>
-              <a:t>‹#›</a:t>
+              <a:t>‹N°›</a:t>
             </a:fld>
             <a:endParaRPr lang="en-US"/>
           </a:p>
@@ -3090,7 +3085,7 @@
 </file>
 
 <file path=ppt/slides/slide1.xml><?xml version="1.0" encoding="utf-8"?>
-<p:sld xmlns:a="http://schemas.openxmlformats.org/drawingml/2006/main" xmlns:p="http://schemas.openxmlformats.org/presentationml/2006/main" xmlns:r="http://schemas.openxmlformats.org/officeDocument/2006/relationships">
+<p:sld xmlns:a="http://schemas.openxmlformats.org/drawingml/2006/main" xmlns:r="http://schemas.openxmlformats.org/officeDocument/2006/relationships" xmlns:p="http://schemas.openxmlformats.org/presentationml/2006/main">
   <p:cSld>
     <p:bg>
       <p:bgPr>
@@ -3106,7 +3101,14 @@
         <p:cNvGrpSpPr/>
         <p:nvPr/>
       </p:nvGrpSpPr>
-      <p:grpSpPr/>
+      <p:grpSpPr>
+        <a:xfrm>
+          <a:off x="0" y="0"/>
+          <a:ext cx="0" cy="0"/>
+          <a:chOff x="0" y="0"/>
+          <a:chExt cx="0" cy="0"/>
+        </a:xfrm>
+      </p:grpSpPr>
       <p:sp>
         <p:nvSpPr>
           <p:cNvPr id="2" name="Rounded Rectangle 1"/>
@@ -3148,14 +3150,29 @@
           <a:p>
             <a:pPr algn="ctr"/>
             <a:r>
-              <a:rPr sz="1600" b="1">
+              <a:rPr sz="1600" b="1" dirty="0">
                 <a:solidFill>
                   <a:srgbClr val="FFFFFF"/>
                 </a:solidFill>
                 <a:latin typeface="Segoe UI"/>
               </a:rPr>
-              <a:t>Sprint review</a:t>
-            </a:r>
+              <a:t>Sprint </a:t>
+            </a:r>
+            <a:r>
+              <a:rPr lang="fr-CA" sz="1600" b="1" dirty="0">
+                <a:solidFill>
+                  <a:srgbClr val="FFFFFF"/>
+                </a:solidFill>
+                <a:latin typeface="Segoe UI"/>
+              </a:rPr>
+              <a:t>5</a:t>
+            </a:r>
+            <a:endParaRPr sz="1600" b="1" dirty="0">
+              <a:solidFill>
+                <a:srgbClr val="FFFFFF"/>
+              </a:solidFill>
+              <a:latin typeface="Segoe UI"/>
+            </a:endParaRPr>
           </a:p>
         </p:txBody>
       </p:sp>
@@ -3202,8 +3219,8 @@
         </p:nvSpPr>
         <p:spPr>
           <a:xfrm>
-            <a:off x="585216" y="1847088"/>
-            <a:ext cx="5303520" cy="914400"/>
+            <a:off x="164592" y="2039219"/>
+            <a:ext cx="3282696" cy="923330"/>
           </a:xfrm>
           <a:prstGeom prst="rect">
             <a:avLst/>
@@ -3211,20 +3228,56 @@
           <a:noFill/>
         </p:spPr>
         <p:txBody>
-          <a:bodyPr wrap="none">
+          <a:bodyPr wrap="square">
             <a:spAutoFit/>
           </a:bodyPr>
           <a:lstStyle/>
           <a:p>
             <a:pPr algn="l"/>
             <a:r>
-              <a:rPr sz="1800" b="0">
+              <a:rPr sz="1800" b="0" dirty="0">
                 <a:solidFill>
                   <a:srgbClr val="475569"/>
                 </a:solidFill>
                 <a:latin typeface="Segoe UI"/>
               </a:rPr>
-              <a:t>Frontend mobile, backend API, stories livrees et point en review pour la demo.</a:t>
+              <a:t>Frontend mobile, backend API, stories </a:t>
+            </a:r>
+            <a:r>
+              <a:rPr sz="1800" b="0" dirty="0" err="1">
+                <a:solidFill>
+                  <a:srgbClr val="475569"/>
+                </a:solidFill>
+                <a:latin typeface="Segoe UI"/>
+              </a:rPr>
+              <a:t>livrees</a:t>
+            </a:r>
+            <a:r>
+              <a:rPr sz="1800" b="0" dirty="0">
+                <a:solidFill>
+                  <a:srgbClr val="475569"/>
+                </a:solidFill>
+                <a:latin typeface="Segoe UI"/>
+              </a:rPr>
+              <a:t> point </a:t>
+            </a:r>
+            <a:r>
+              <a:rPr sz="1800" b="0" dirty="0" err="1">
+                <a:solidFill>
+                  <a:srgbClr val="475569"/>
+                </a:solidFill>
+                <a:latin typeface="Segoe UI"/>
+              </a:rPr>
+              <a:t>en</a:t>
+            </a:r>
+            <a:r>
+              <a:rPr sz="1800" b="0" dirty="0">
+                <a:solidFill>
+                  <a:srgbClr val="475569"/>
+                </a:solidFill>
+                <a:latin typeface="Segoe UI"/>
+              </a:rPr>
+              <a:t> review pour la demo.</a:t>
             </a:r>
           </a:p>
         </p:txBody>
@@ -3237,7 +3290,7 @@
         </p:nvSpPr>
         <p:spPr>
           <a:xfrm>
-            <a:off x="585216" y="2578608"/>
+            <a:off x="265176" y="3328416"/>
             <a:ext cx="4572000" cy="256032"/>
           </a:xfrm>
           <a:prstGeom prst="rect">
@@ -3280,8 +3333,8 @@
         </p:blipFill>
         <p:spPr>
           <a:xfrm>
-            <a:off x="5486400" y="768096"/>
-            <a:ext cx="6080760" cy="5440680"/>
+            <a:off x="6071616" y="1693925"/>
+            <a:ext cx="6080760" cy="3781045"/>
           </a:xfrm>
           <a:prstGeom prst="rect">
             <a:avLst/>
@@ -3349,7 +3402,7 @@
 </file>
 
 <file path=ppt/slides/slide10.xml><?xml version="1.0" encoding="utf-8"?>
-<p:sld xmlns:a="http://schemas.openxmlformats.org/drawingml/2006/main" xmlns:p="http://schemas.openxmlformats.org/presentationml/2006/main" xmlns:r="http://schemas.openxmlformats.org/officeDocument/2006/relationships">
+<p:sld xmlns:a="http://schemas.openxmlformats.org/drawingml/2006/main" xmlns:r="http://schemas.openxmlformats.org/officeDocument/2006/relationships" xmlns:p="http://schemas.openxmlformats.org/presentationml/2006/main">
   <p:cSld>
     <p:bg>
       <p:bgPr>
@@ -3365,7 +3418,14 @@
         <p:cNvGrpSpPr/>
         <p:nvPr/>
       </p:nvGrpSpPr>
-      <p:grpSpPr/>
+      <p:grpSpPr>
+        <a:xfrm>
+          <a:off x="0" y="0"/>
+          <a:ext cx="0" cy="0"/>
+          <a:chOff x="0" y="0"/>
+          <a:chExt cx="0" cy="0"/>
+        </a:xfrm>
+      </p:grpSpPr>
       <p:sp>
         <p:nvSpPr>
           <p:cNvPr id="2" name="Rounded Rectangle 1"/>
@@ -3514,7 +3574,7 @@
         <p:spPr>
           <a:xfrm>
             <a:off x="530352" y="932688"/>
-            <a:ext cx="10881360" cy="256032"/>
+            <a:ext cx="3366627" cy="261610"/>
           </a:xfrm>
           <a:prstGeom prst="rect">
             <a:avLst/>
@@ -3529,13 +3589,31 @@
           <a:p>
             <a:pPr algn="l"/>
             <a:r>
-              <a:rPr sz="1100" b="0">
+              <a:rPr sz="1100" b="0" dirty="0">
                 <a:solidFill>
                   <a:srgbClr val="475569"/>
                 </a:solidFill>
                 <a:latin typeface="Segoe UI"/>
               </a:rPr>
-              <a:t>Sprint review - application mobile garage et API backend</a:t>
+              <a:t>Sprint </a:t>
+            </a:r>
+            <a:r>
+              <a:rPr lang="fr-CA" sz="1100" b="0" dirty="0">
+                <a:solidFill>
+                  <a:srgbClr val="475569"/>
+                </a:solidFill>
+                <a:latin typeface="Segoe UI"/>
+              </a:rPr>
+              <a:t>5</a:t>
+            </a:r>
+            <a:r>
+              <a:rPr sz="1100" b="0" dirty="0">
+                <a:solidFill>
+                  <a:srgbClr val="475569"/>
+                </a:solidFill>
+                <a:latin typeface="Segoe UI"/>
+              </a:rPr>
+              <a:t>- application mobile garage et API backend</a:t>
             </a:r>
           </a:p>
         </p:txBody>
@@ -3600,7 +3678,7 @@
           </a:fontRef>
         </p:style>
         <p:txBody>
-          <a:bodyPr rtlCol="0" anchor="ctr" lIns="182880" rIns="137160" tIns="137160" bIns="91440"/>
+          <a:bodyPr lIns="182880" tIns="137160" rIns="137160" bIns="91440" rtlCol="0" anchor="ctr"/>
           <a:lstStyle/>
           <a:p>
             <a:pPr algn="ctr"/>
@@ -3756,7 +3834,7 @@
 </file>
 
 <file path=ppt/slides/slide11.xml><?xml version="1.0" encoding="utf-8"?>
-<p:sld xmlns:a="http://schemas.openxmlformats.org/drawingml/2006/main" xmlns:p="http://schemas.openxmlformats.org/presentationml/2006/main" xmlns:r="http://schemas.openxmlformats.org/officeDocument/2006/relationships">
+<p:sld xmlns:a="http://schemas.openxmlformats.org/drawingml/2006/main" xmlns:r="http://schemas.openxmlformats.org/officeDocument/2006/relationships" xmlns:p="http://schemas.openxmlformats.org/presentationml/2006/main">
   <p:cSld>
     <p:bg>
       <p:bgPr>
@@ -3772,7 +3850,14 @@
         <p:cNvGrpSpPr/>
         <p:nvPr/>
       </p:nvGrpSpPr>
-      <p:grpSpPr/>
+      <p:grpSpPr>
+        <a:xfrm>
+          <a:off x="0" y="0"/>
+          <a:ext cx="0" cy="0"/>
+          <a:chOff x="0" y="0"/>
+          <a:chExt cx="0" cy="0"/>
+        </a:xfrm>
+      </p:grpSpPr>
       <p:sp>
         <p:nvSpPr>
           <p:cNvPr id="2" name="Rounded Rectangle 1"/>
@@ -3921,7 +4006,7 @@
         <p:spPr>
           <a:xfrm>
             <a:off x="530352" y="932688"/>
-            <a:ext cx="10881360" cy="256032"/>
+            <a:ext cx="3405099" cy="261610"/>
           </a:xfrm>
           <a:prstGeom prst="rect">
             <a:avLst/>
@@ -3936,13 +4021,31 @@
           <a:p>
             <a:pPr algn="l"/>
             <a:r>
-              <a:rPr sz="1100" b="0">
+              <a:rPr sz="1100" b="0" dirty="0">
                 <a:solidFill>
                   <a:srgbClr val="475569"/>
                 </a:solidFill>
                 <a:latin typeface="Segoe UI"/>
               </a:rPr>
-              <a:t>Sprint review - application mobile garage et API backend</a:t>
+              <a:t>Sprint </a:t>
+            </a:r>
+            <a:r>
+              <a:rPr lang="fr-CA" sz="1100" b="0" dirty="0">
+                <a:solidFill>
+                  <a:srgbClr val="475569"/>
+                </a:solidFill>
+                <a:latin typeface="Segoe UI"/>
+              </a:rPr>
+              <a:t>5</a:t>
+            </a:r>
+            <a:r>
+              <a:rPr sz="1100" b="0" dirty="0">
+                <a:solidFill>
+                  <a:srgbClr val="475569"/>
+                </a:solidFill>
+                <a:latin typeface="Segoe UI"/>
+              </a:rPr>
+              <a:t> - application mobile garage et API backend</a:t>
             </a:r>
           </a:p>
         </p:txBody>
@@ -4007,7 +4110,7 @@
           </a:fontRef>
         </p:style>
         <p:txBody>
-          <a:bodyPr rtlCol="0" anchor="ctr" lIns="182880" rIns="137160" tIns="137160" bIns="91440"/>
+          <a:bodyPr lIns="182880" tIns="137160" rIns="137160" bIns="91440" rtlCol="0" anchor="ctr"/>
           <a:lstStyle/>
           <a:p>
             <a:pPr algn="ctr"/>
@@ -4163,7 +4266,7 @@
 </file>
 
 <file path=ppt/slides/slide12.xml><?xml version="1.0" encoding="utf-8"?>
-<p:sld xmlns:a="http://schemas.openxmlformats.org/drawingml/2006/main" xmlns:p="http://schemas.openxmlformats.org/presentationml/2006/main" xmlns:r="http://schemas.openxmlformats.org/officeDocument/2006/relationships">
+<p:sld xmlns:a="http://schemas.openxmlformats.org/drawingml/2006/main" xmlns:r="http://schemas.openxmlformats.org/officeDocument/2006/relationships" xmlns:p="http://schemas.openxmlformats.org/presentationml/2006/main">
   <p:cSld>
     <p:bg>
       <p:bgPr>
@@ -4179,7 +4282,14 @@
         <p:cNvGrpSpPr/>
         <p:nvPr/>
       </p:nvGrpSpPr>
-      <p:grpSpPr/>
+      <p:grpSpPr>
+        <a:xfrm>
+          <a:off x="0" y="0"/>
+          <a:ext cx="0" cy="0"/>
+          <a:chOff x="0" y="0"/>
+          <a:chExt cx="0" cy="0"/>
+        </a:xfrm>
+      </p:grpSpPr>
       <p:sp>
         <p:nvSpPr>
           <p:cNvPr id="2" name="Rounded Rectangle 1"/>
@@ -4328,7 +4438,7 @@
         <p:spPr>
           <a:xfrm>
             <a:off x="530352" y="932688"/>
-            <a:ext cx="10881360" cy="256032"/>
+            <a:ext cx="3405099" cy="261610"/>
           </a:xfrm>
           <a:prstGeom prst="rect">
             <a:avLst/>
@@ -4343,13 +4453,31 @@
           <a:p>
             <a:pPr algn="l"/>
             <a:r>
-              <a:rPr sz="1100" b="0">
+              <a:rPr sz="1100" b="0" dirty="0">
                 <a:solidFill>
                   <a:srgbClr val="475569"/>
                 </a:solidFill>
                 <a:latin typeface="Segoe UI"/>
               </a:rPr>
-              <a:t>Sprint review - application mobile garage et API backend</a:t>
+              <a:t>Sprint </a:t>
+            </a:r>
+            <a:r>
+              <a:rPr lang="fr-CA" sz="1100" b="0" dirty="0">
+                <a:solidFill>
+                  <a:srgbClr val="475569"/>
+                </a:solidFill>
+                <a:latin typeface="Segoe UI"/>
+              </a:rPr>
+              <a:t>5</a:t>
+            </a:r>
+            <a:r>
+              <a:rPr sz="1100" b="0" dirty="0">
+                <a:solidFill>
+                  <a:srgbClr val="475569"/>
+                </a:solidFill>
+                <a:latin typeface="Segoe UI"/>
+              </a:rPr>
+              <a:t> - application mobile garage et API backend</a:t>
             </a:r>
           </a:p>
         </p:txBody>
@@ -4414,7 +4542,7 @@
           </a:fontRef>
         </p:style>
         <p:txBody>
-          <a:bodyPr rtlCol="0" anchor="ctr" lIns="182880" rIns="137160" tIns="137160" bIns="91440"/>
+          <a:bodyPr lIns="182880" tIns="137160" rIns="137160" bIns="91440" rtlCol="0" anchor="ctr"/>
           <a:lstStyle/>
           <a:p>
             <a:pPr algn="ctr"/>
@@ -4570,7 +4698,7 @@
 </file>
 
 <file path=ppt/slides/slide2.xml><?xml version="1.0" encoding="utf-8"?>
-<p:sld xmlns:a="http://schemas.openxmlformats.org/drawingml/2006/main" xmlns:p="http://schemas.openxmlformats.org/presentationml/2006/main" xmlns:r="http://schemas.openxmlformats.org/officeDocument/2006/relationships">
+<p:sld xmlns:a="http://schemas.openxmlformats.org/drawingml/2006/main" xmlns:r="http://schemas.openxmlformats.org/officeDocument/2006/relationships" xmlns:p="http://schemas.openxmlformats.org/presentationml/2006/main">
   <p:cSld>
     <p:bg>
       <p:bgPr>
@@ -4586,7 +4714,14 @@
         <p:cNvGrpSpPr/>
         <p:nvPr/>
       </p:nvGrpSpPr>
-      <p:grpSpPr/>
+      <p:grpSpPr>
+        <a:xfrm>
+          <a:off x="0" y="0"/>
+          <a:ext cx="0" cy="0"/>
+          <a:chOff x="0" y="0"/>
+          <a:chExt cx="0" cy="0"/>
+        </a:xfrm>
+      </p:grpSpPr>
       <p:sp>
         <p:nvSpPr>
           <p:cNvPr id="2" name="Rounded Rectangle 1"/>
@@ -4735,7 +4870,7 @@
         <p:spPr>
           <a:xfrm>
             <a:off x="530352" y="932688"/>
-            <a:ext cx="10881360" cy="256032"/>
+            <a:ext cx="3340979" cy="261610"/>
           </a:xfrm>
           <a:prstGeom prst="rect">
             <a:avLst/>
@@ -4750,13 +4885,31 @@
           <a:p>
             <a:pPr algn="l"/>
             <a:r>
-              <a:rPr sz="1100" b="0">
+              <a:rPr sz="1100" b="0" dirty="0">
                 <a:solidFill>
                   <a:srgbClr val="475569"/>
                 </a:solidFill>
                 <a:latin typeface="Segoe UI"/>
               </a:rPr>
-              <a:t>Sprint review - application mobile garage et API backend</a:t>
+              <a:t>Sprint </a:t>
+            </a:r>
+            <a:r>
+              <a:rPr lang="fr-CA" sz="1100" dirty="0">
+                <a:solidFill>
+                  <a:srgbClr val="475569"/>
+                </a:solidFill>
+                <a:latin typeface="Segoe UI"/>
+              </a:rPr>
+              <a:t>5</a:t>
+            </a:r>
+            <a:r>
+              <a:rPr sz="1100" b="0" dirty="0">
+                <a:solidFill>
+                  <a:srgbClr val="475569"/>
+                </a:solidFill>
+                <a:latin typeface="Segoe UI"/>
+              </a:rPr>
+              <a:t>- application mobile garage et API backend</a:t>
             </a:r>
           </a:p>
         </p:txBody>
@@ -4821,7 +4974,7 @@
           </a:fontRef>
         </p:style>
         <p:txBody>
-          <a:bodyPr rtlCol="0" anchor="ctr" lIns="182880" rIns="137160" tIns="137160" bIns="91440"/>
+          <a:bodyPr lIns="182880" tIns="137160" rIns="137160" bIns="91440" rtlCol="0" anchor="ctr"/>
           <a:lstStyle/>
           <a:p>
             <a:pPr algn="ctr"/>
@@ -4977,7 +5130,7 @@
 </file>
 
 <file path=ppt/slides/slide3.xml><?xml version="1.0" encoding="utf-8"?>
-<p:sld xmlns:a="http://schemas.openxmlformats.org/drawingml/2006/main" xmlns:p="http://schemas.openxmlformats.org/presentationml/2006/main" xmlns:r="http://schemas.openxmlformats.org/officeDocument/2006/relationships">
+<p:sld xmlns:a="http://schemas.openxmlformats.org/drawingml/2006/main" xmlns:r="http://schemas.openxmlformats.org/officeDocument/2006/relationships" xmlns:p="http://schemas.openxmlformats.org/presentationml/2006/main">
   <p:cSld>
     <p:bg>
       <p:bgPr>
@@ -4993,7 +5146,14 @@
         <p:cNvGrpSpPr/>
         <p:nvPr/>
       </p:nvGrpSpPr>
-      <p:grpSpPr/>
+      <p:grpSpPr>
+        <a:xfrm>
+          <a:off x="0" y="0"/>
+          <a:ext cx="0" cy="0"/>
+          <a:chOff x="0" y="0"/>
+          <a:chExt cx="0" cy="0"/>
+        </a:xfrm>
+      </p:grpSpPr>
       <p:sp>
         <p:nvSpPr>
           <p:cNvPr id="2" name="Rounded Rectangle 1"/>
@@ -5142,7 +5302,7 @@
         <p:spPr>
           <a:xfrm>
             <a:off x="530352" y="932688"/>
-            <a:ext cx="10881360" cy="256032"/>
+            <a:ext cx="3453189" cy="261610"/>
           </a:xfrm>
           <a:prstGeom prst="rect">
             <a:avLst/>
@@ -5157,13 +5317,31 @@
           <a:p>
             <a:pPr algn="l"/>
             <a:r>
-              <a:rPr sz="1100" b="0">
+              <a:rPr sz="1100" b="0" dirty="0">
                 <a:solidFill>
                   <a:srgbClr val="475569"/>
                 </a:solidFill>
                 <a:latin typeface="Segoe UI"/>
               </a:rPr>
-              <a:t>Sprint review - application mobile garage et API backend</a:t>
+              <a:t>Sprint </a:t>
+            </a:r>
+            <a:r>
+              <a:rPr lang="fr-CA" sz="1100" dirty="0">
+                <a:solidFill>
+                  <a:srgbClr val="475569"/>
+                </a:solidFill>
+                <a:latin typeface="Segoe UI"/>
+              </a:rPr>
+              <a:t>5</a:t>
+            </a:r>
+            <a:r>
+              <a:rPr sz="1100" b="0" dirty="0">
+                <a:solidFill>
+                  <a:srgbClr val="475569"/>
+                </a:solidFill>
+                <a:latin typeface="Segoe UI"/>
+              </a:rPr>
+              <a:t> - application mobile garage et API backend</a:t>
             </a:r>
           </a:p>
         </p:txBody>
@@ -5228,7 +5406,7 @@
           </a:fontRef>
         </p:style>
         <p:txBody>
-          <a:bodyPr rtlCol="0" anchor="ctr" lIns="182880" rIns="137160" tIns="137160" bIns="91440"/>
+          <a:bodyPr lIns="182880" tIns="137160" rIns="137160" bIns="91440" rtlCol="0" anchor="ctr"/>
           <a:lstStyle/>
           <a:p>
             <a:pPr algn="ctr"/>
@@ -5384,7 +5562,7 @@
 </file>
 
 <file path=ppt/slides/slide4.xml><?xml version="1.0" encoding="utf-8"?>
-<p:sld xmlns:a="http://schemas.openxmlformats.org/drawingml/2006/main" xmlns:p="http://schemas.openxmlformats.org/presentationml/2006/main" xmlns:r="http://schemas.openxmlformats.org/officeDocument/2006/relationships">
+<p:sld xmlns:a="http://schemas.openxmlformats.org/drawingml/2006/main" xmlns:r="http://schemas.openxmlformats.org/officeDocument/2006/relationships" xmlns:p="http://schemas.openxmlformats.org/presentationml/2006/main">
   <p:cSld>
     <p:bg>
       <p:bgPr>
@@ -5400,7 +5578,14 @@
         <p:cNvGrpSpPr/>
         <p:nvPr/>
       </p:nvGrpSpPr>
-      <p:grpSpPr/>
+      <p:grpSpPr>
+        <a:xfrm>
+          <a:off x="0" y="0"/>
+          <a:ext cx="0" cy="0"/>
+          <a:chOff x="0" y="0"/>
+          <a:chExt cx="0" cy="0"/>
+        </a:xfrm>
+      </p:grpSpPr>
       <p:sp>
         <p:nvSpPr>
           <p:cNvPr id="2" name="Rounded Rectangle 1"/>
@@ -5549,7 +5734,7 @@
         <p:spPr>
           <a:xfrm>
             <a:off x="530352" y="932688"/>
-            <a:ext cx="10881360" cy="256032"/>
+            <a:ext cx="3340979" cy="261610"/>
           </a:xfrm>
           <a:prstGeom prst="rect">
             <a:avLst/>
@@ -5564,13 +5749,31 @@
           <a:p>
             <a:pPr algn="l"/>
             <a:r>
-              <a:rPr sz="1100" b="0">
+              <a:rPr sz="1100" b="0" dirty="0">
                 <a:solidFill>
                   <a:srgbClr val="475569"/>
                 </a:solidFill>
                 <a:latin typeface="Segoe UI"/>
               </a:rPr>
-              <a:t>Sprint review - application mobile garage et API backend</a:t>
+              <a:t>Sprint </a:t>
+            </a:r>
+            <a:r>
+              <a:rPr lang="fr-CA" sz="1100" dirty="0">
+                <a:solidFill>
+                  <a:srgbClr val="475569"/>
+                </a:solidFill>
+                <a:latin typeface="Segoe UI"/>
+              </a:rPr>
+              <a:t>5</a:t>
+            </a:r>
+            <a:r>
+              <a:rPr sz="1100" b="0" dirty="0">
+                <a:solidFill>
+                  <a:srgbClr val="475569"/>
+                </a:solidFill>
+                <a:latin typeface="Segoe UI"/>
+              </a:rPr>
+              <a:t>- application mobile garage et API backend</a:t>
             </a:r>
           </a:p>
         </p:txBody>
@@ -5635,7 +5838,7 @@
           </a:fontRef>
         </p:style>
         <p:txBody>
-          <a:bodyPr rtlCol="0" anchor="ctr" lIns="182880" rIns="137160" tIns="137160" bIns="91440"/>
+          <a:bodyPr lIns="182880" tIns="137160" rIns="137160" bIns="91440" rtlCol="0" anchor="ctr"/>
           <a:lstStyle/>
           <a:p>
             <a:pPr algn="ctr"/>
@@ -5791,7 +5994,7 @@
 </file>
 
 <file path=ppt/slides/slide5.xml><?xml version="1.0" encoding="utf-8"?>
-<p:sld xmlns:a="http://schemas.openxmlformats.org/drawingml/2006/main" xmlns:p="http://schemas.openxmlformats.org/presentationml/2006/main" xmlns:r="http://schemas.openxmlformats.org/officeDocument/2006/relationships">
+<p:sld xmlns:a="http://schemas.openxmlformats.org/drawingml/2006/main" xmlns:r="http://schemas.openxmlformats.org/officeDocument/2006/relationships" xmlns:p="http://schemas.openxmlformats.org/presentationml/2006/main">
   <p:cSld>
     <p:bg>
       <p:bgPr>
@@ -5807,7 +6010,14 @@
         <p:cNvGrpSpPr/>
         <p:nvPr/>
       </p:nvGrpSpPr>
-      <p:grpSpPr/>
+      <p:grpSpPr>
+        <a:xfrm>
+          <a:off x="0" y="0"/>
+          <a:ext cx="0" cy="0"/>
+          <a:chOff x="0" y="0"/>
+          <a:chExt cx="0" cy="0"/>
+        </a:xfrm>
+      </p:grpSpPr>
       <p:sp>
         <p:nvSpPr>
           <p:cNvPr id="2" name="Rounded Rectangle 1"/>
@@ -5956,7 +6166,7 @@
         <p:spPr>
           <a:xfrm>
             <a:off x="530352" y="932688"/>
-            <a:ext cx="10881360" cy="256032"/>
+            <a:ext cx="3453189" cy="261610"/>
           </a:xfrm>
           <a:prstGeom prst="rect">
             <a:avLst/>
@@ -5971,13 +6181,31 @@
           <a:p>
             <a:pPr algn="l"/>
             <a:r>
-              <a:rPr sz="1100" b="0">
+              <a:rPr sz="1100" b="0" dirty="0">
                 <a:solidFill>
                   <a:srgbClr val="475569"/>
                 </a:solidFill>
                 <a:latin typeface="Segoe UI"/>
               </a:rPr>
-              <a:t>Sprint review - application mobile garage et API backend</a:t>
+              <a:t>Sprint </a:t>
+            </a:r>
+            <a:r>
+              <a:rPr lang="fr-CA" sz="1100" dirty="0">
+                <a:solidFill>
+                  <a:srgbClr val="475569"/>
+                </a:solidFill>
+                <a:latin typeface="Segoe UI"/>
+              </a:rPr>
+              <a:t>5</a:t>
+            </a:r>
+            <a:r>
+              <a:rPr sz="1100" b="0" dirty="0">
+                <a:solidFill>
+                  <a:srgbClr val="475569"/>
+                </a:solidFill>
+                <a:latin typeface="Segoe UI"/>
+              </a:rPr>
+              <a:t> - application mobile garage et API backend</a:t>
             </a:r>
           </a:p>
         </p:txBody>
@@ -6042,7 +6270,7 @@
           </a:fontRef>
         </p:style>
         <p:txBody>
-          <a:bodyPr rtlCol="0" anchor="ctr" lIns="182880" rIns="137160" tIns="137160" bIns="91440"/>
+          <a:bodyPr lIns="182880" tIns="137160" rIns="137160" bIns="91440" rtlCol="0" anchor="ctr"/>
           <a:lstStyle/>
           <a:p>
             <a:pPr algn="ctr"/>
@@ -6174,7 +6402,7 @@
 </file>
 
 <file path=ppt/slides/slide6.xml><?xml version="1.0" encoding="utf-8"?>
-<p:sld xmlns:a="http://schemas.openxmlformats.org/drawingml/2006/main" xmlns:p="http://schemas.openxmlformats.org/presentationml/2006/main" xmlns:r="http://schemas.openxmlformats.org/officeDocument/2006/relationships">
+<p:sld xmlns:a="http://schemas.openxmlformats.org/drawingml/2006/main" xmlns:r="http://schemas.openxmlformats.org/officeDocument/2006/relationships" xmlns:p="http://schemas.openxmlformats.org/presentationml/2006/main">
   <p:cSld>
     <p:bg>
       <p:bgPr>
@@ -6190,7 +6418,14 @@
         <p:cNvGrpSpPr/>
         <p:nvPr/>
       </p:nvGrpSpPr>
-      <p:grpSpPr/>
+      <p:grpSpPr>
+        <a:xfrm>
+          <a:off x="0" y="0"/>
+          <a:ext cx="0" cy="0"/>
+          <a:chOff x="0" y="0"/>
+          <a:chExt cx="0" cy="0"/>
+        </a:xfrm>
+      </p:grpSpPr>
       <p:sp>
         <p:nvSpPr>
           <p:cNvPr id="2" name="Rounded Rectangle 1"/>
@@ -6339,7 +6574,7 @@
         <p:spPr>
           <a:xfrm>
             <a:off x="530352" y="932688"/>
-            <a:ext cx="10881360" cy="256032"/>
+            <a:ext cx="3453189" cy="261610"/>
           </a:xfrm>
           <a:prstGeom prst="rect">
             <a:avLst/>
@@ -6354,13 +6589,31 @@
           <a:p>
             <a:pPr algn="l"/>
             <a:r>
-              <a:rPr sz="1100" b="0">
+              <a:rPr sz="1100" b="0" dirty="0">
                 <a:solidFill>
                   <a:srgbClr val="475569"/>
                 </a:solidFill>
                 <a:latin typeface="Segoe UI"/>
               </a:rPr>
-              <a:t>Sprint review - application mobile garage et API backend</a:t>
+              <a:t>Sprint </a:t>
+            </a:r>
+            <a:r>
+              <a:rPr lang="fr-CA" sz="1100" dirty="0">
+                <a:solidFill>
+                  <a:srgbClr val="475569"/>
+                </a:solidFill>
+                <a:latin typeface="Segoe UI"/>
+              </a:rPr>
+              <a:t>5</a:t>
+            </a:r>
+            <a:r>
+              <a:rPr sz="1100" b="0" dirty="0">
+                <a:solidFill>
+                  <a:srgbClr val="475569"/>
+                </a:solidFill>
+                <a:latin typeface="Segoe UI"/>
+              </a:rPr>
+              <a:t> - application mobile garage et API backend</a:t>
             </a:r>
           </a:p>
         </p:txBody>
@@ -6425,7 +6678,7 @@
           </a:fontRef>
         </p:style>
         <p:txBody>
-          <a:bodyPr rtlCol="0" anchor="ctr" lIns="182880" rIns="137160" tIns="137160" bIns="91440"/>
+          <a:bodyPr lIns="182880" tIns="137160" rIns="137160" bIns="91440" rtlCol="0" anchor="ctr"/>
           <a:lstStyle/>
           <a:p>
             <a:pPr algn="ctr"/>
@@ -6557,7 +6810,7 @@
 </file>
 
 <file path=ppt/slides/slide7.xml><?xml version="1.0" encoding="utf-8"?>
-<p:sld xmlns:a="http://schemas.openxmlformats.org/drawingml/2006/main" xmlns:p="http://schemas.openxmlformats.org/presentationml/2006/main" xmlns:r="http://schemas.openxmlformats.org/officeDocument/2006/relationships">
+<p:sld xmlns:a="http://schemas.openxmlformats.org/drawingml/2006/main" xmlns:r="http://schemas.openxmlformats.org/officeDocument/2006/relationships" xmlns:p="http://schemas.openxmlformats.org/presentationml/2006/main">
   <p:cSld>
     <p:bg>
       <p:bgPr>
@@ -6573,7 +6826,14 @@
         <p:cNvGrpSpPr/>
         <p:nvPr/>
       </p:nvGrpSpPr>
-      <p:grpSpPr/>
+      <p:grpSpPr>
+        <a:xfrm>
+          <a:off x="0" y="0"/>
+          <a:ext cx="0" cy="0"/>
+          <a:chOff x="0" y="0"/>
+          <a:chExt cx="0" cy="0"/>
+        </a:xfrm>
+      </p:grpSpPr>
       <p:sp>
         <p:nvSpPr>
           <p:cNvPr id="2" name="Rounded Rectangle 1"/>
@@ -6722,7 +6982,7 @@
         <p:spPr>
           <a:xfrm>
             <a:off x="530352" y="932688"/>
-            <a:ext cx="10881360" cy="256032"/>
+            <a:ext cx="3366627" cy="261610"/>
           </a:xfrm>
           <a:prstGeom prst="rect">
             <a:avLst/>
@@ -6737,13 +6997,31 @@
           <a:p>
             <a:pPr algn="l"/>
             <a:r>
-              <a:rPr sz="1100" b="0">
+              <a:rPr sz="1100" b="0" dirty="0">
                 <a:solidFill>
                   <a:srgbClr val="475569"/>
                 </a:solidFill>
                 <a:latin typeface="Segoe UI"/>
               </a:rPr>
-              <a:t>Sprint review - application mobile garage et API backend</a:t>
+              <a:t>Sprint</a:t>
+            </a:r>
+            <a:r>
+              <a:rPr lang="fr-CA" sz="1100" b="0" dirty="0">
+                <a:solidFill>
+                  <a:srgbClr val="475569"/>
+                </a:solidFill>
+                <a:latin typeface="Segoe UI"/>
+              </a:rPr>
+              <a:t> 5</a:t>
+            </a:r>
+            <a:r>
+              <a:rPr sz="1100" b="0" dirty="0">
+                <a:solidFill>
+                  <a:srgbClr val="475569"/>
+                </a:solidFill>
+                <a:latin typeface="Segoe UI"/>
+              </a:rPr>
+              <a:t>- application mobile garage et API backend</a:t>
             </a:r>
           </a:p>
         </p:txBody>
@@ -6808,19 +7086,34 @@
           </a:fontRef>
         </p:style>
         <p:txBody>
-          <a:bodyPr rtlCol="0" anchor="ctr" lIns="182880" rIns="137160" tIns="137160" bIns="91440"/>
+          <a:bodyPr lIns="182880" tIns="137160" rIns="137160" bIns="91440" rtlCol="0" anchor="ctr"/>
           <a:lstStyle/>
           <a:p>
             <a:pPr algn="ctr"/>
             <a:r>
-              <a:rPr sz="1800" b="1">
+              <a:rPr sz="1800" b="1" dirty="0">
                 <a:solidFill>
                   <a:srgbClr val="171F2C"/>
                 </a:solidFill>
                 <a:latin typeface="Segoe UI"/>
               </a:rPr>
-              <a:t>Points cles</a:t>
-            </a:r>
+              <a:t>Points </a:t>
+            </a:r>
+            <a:r>
+              <a:rPr sz="1800" b="1" dirty="0" err="1">
+                <a:solidFill>
+                  <a:srgbClr val="171F2C"/>
+                </a:solidFill>
+                <a:latin typeface="Segoe UI"/>
+              </a:rPr>
+              <a:t>cles</a:t>
+            </a:r>
+            <a:endParaRPr sz="1800" b="1" dirty="0">
+              <a:solidFill>
+                <a:srgbClr val="171F2C"/>
+              </a:solidFill>
+              <a:latin typeface="Segoe UI"/>
+            </a:endParaRPr>
           </a:p>
           <a:p>
             <a:pPr>
@@ -6835,7 +7128,64 @@
               </a:defRPr>
             </a:pPr>
             <a:r>
-              <a:t>- Depuis Mes rendez-vous, l'utilisateur peut reouvrir un RDV existant en edition.</a:t>
+              <a:rPr dirty="0"/>
+              <a:t>- </a:t>
+            </a:r>
+            <a:r>
+              <a:rPr dirty="0" err="1"/>
+              <a:t>Depuis</a:t>
+            </a:r>
+            <a:r>
+              <a:rPr dirty="0"/>
+              <a:t> Mes </a:t>
+            </a:r>
+            <a:r>
+              <a:rPr dirty="0" err="1"/>
+              <a:t>rendez</a:t>
+            </a:r>
+            <a:r>
+              <a:rPr dirty="0"/>
+              <a:t>-vous, </a:t>
+            </a:r>
+            <a:r>
+              <a:rPr dirty="0" err="1"/>
+              <a:t>l'utilisateur</a:t>
+            </a:r>
+            <a:r>
+              <a:rPr dirty="0"/>
+              <a:t> </a:t>
+            </a:r>
+            <a:r>
+              <a:rPr dirty="0" err="1"/>
+              <a:t>peut</a:t>
+            </a:r>
+            <a:r>
+              <a:rPr dirty="0"/>
+              <a:t> </a:t>
+            </a:r>
+            <a:r>
+              <a:rPr dirty="0" err="1"/>
+              <a:t>reouvrir</a:t>
+            </a:r>
+            <a:r>
+              <a:rPr dirty="0"/>
+              <a:t> un RDV </a:t>
+            </a:r>
+            <a:r>
+              <a:rPr dirty="0" err="1"/>
+              <a:t>existant</a:t>
+            </a:r>
+            <a:r>
+              <a:rPr dirty="0"/>
+              <a:t> </a:t>
+            </a:r>
+            <a:r>
+              <a:rPr dirty="0" err="1"/>
+              <a:t>en</a:t>
+            </a:r>
+            <a:r>
+              <a:rPr dirty="0"/>
+              <a:t> edition.</a:t>
             </a:r>
           </a:p>
           <a:p>
@@ -6851,7 +7201,32 @@
               </a:defRPr>
             </a:pPr>
             <a:r>
-              <a:t>- Le formulaire reservation recharge service, vehicule, date et creneau.</a:t>
+              <a:rPr dirty="0"/>
+              <a:t>- Le </a:t>
+            </a:r>
+            <a:r>
+              <a:rPr dirty="0" err="1"/>
+              <a:t>formulaire</a:t>
+            </a:r>
+            <a:r>
+              <a:rPr dirty="0"/>
+              <a:t> reservation recharge service, </a:t>
+            </a:r>
+            <a:r>
+              <a:rPr dirty="0" err="1"/>
+              <a:t>vehicule</a:t>
+            </a:r>
+            <a:r>
+              <a:rPr dirty="0"/>
+              <a:t>, date et </a:t>
+            </a:r>
+            <a:r>
+              <a:rPr dirty="0" err="1"/>
+              <a:t>creneau</a:t>
+            </a:r>
+            <a:r>
+              <a:rPr dirty="0"/>
+              <a:t>.</a:t>
             </a:r>
           </a:p>
           <a:p>
@@ -6867,7 +7242,32 @@
               </a:defRPr>
             </a:pPr>
             <a:r>
-              <a:t>- Le backend reverifie les disponibilites avant de persister la mise a jour.</a:t>
+              <a:rPr dirty="0"/>
+              <a:t>- Le backend </a:t>
+            </a:r>
+            <a:r>
+              <a:rPr dirty="0" err="1"/>
+              <a:t>reverifie</a:t>
+            </a:r>
+            <a:r>
+              <a:rPr dirty="0"/>
+              <a:t> les </a:t>
+            </a:r>
+            <a:r>
+              <a:rPr dirty="0" err="1"/>
+              <a:t>disponibilites</a:t>
+            </a:r>
+            <a:r>
+              <a:rPr dirty="0"/>
+              <a:t> avant de </a:t>
+            </a:r>
+            <a:r>
+              <a:rPr dirty="0" err="1"/>
+              <a:t>persister</a:t>
+            </a:r>
+            <a:r>
+              <a:rPr dirty="0"/>
+              <a:t> la mise a jour.</a:t>
             </a:r>
           </a:p>
         </p:txBody>
@@ -6964,7 +7364,7 @@
 </file>
 
 <file path=ppt/slides/slide8.xml><?xml version="1.0" encoding="utf-8"?>
-<p:sld xmlns:a="http://schemas.openxmlformats.org/drawingml/2006/main" xmlns:p="http://schemas.openxmlformats.org/presentationml/2006/main" xmlns:r="http://schemas.openxmlformats.org/officeDocument/2006/relationships">
+<p:sld xmlns:a="http://schemas.openxmlformats.org/drawingml/2006/main" xmlns:r="http://schemas.openxmlformats.org/officeDocument/2006/relationships" xmlns:p="http://schemas.openxmlformats.org/presentationml/2006/main">
   <p:cSld>
     <p:bg>
       <p:bgPr>
@@ -6980,7 +7380,14 @@
         <p:cNvGrpSpPr/>
         <p:nvPr/>
       </p:nvGrpSpPr>
-      <p:grpSpPr/>
+      <p:grpSpPr>
+        <a:xfrm>
+          <a:off x="0" y="0"/>
+          <a:ext cx="0" cy="0"/>
+          <a:chOff x="0" y="0"/>
+          <a:chExt cx="0" cy="0"/>
+        </a:xfrm>
+      </p:grpSpPr>
       <p:sp>
         <p:nvSpPr>
           <p:cNvPr id="2" name="Rounded Rectangle 1"/>
@@ -7129,7 +7536,7 @@
         <p:spPr>
           <a:xfrm>
             <a:off x="530352" y="932688"/>
-            <a:ext cx="10881360" cy="256032"/>
+            <a:ext cx="3405099" cy="261610"/>
           </a:xfrm>
           <a:prstGeom prst="rect">
             <a:avLst/>
@@ -7144,13 +7551,31 @@
           <a:p>
             <a:pPr algn="l"/>
             <a:r>
-              <a:rPr sz="1100" b="0">
+              <a:rPr sz="1100" b="0" dirty="0">
                 <a:solidFill>
                   <a:srgbClr val="475569"/>
                 </a:solidFill>
                 <a:latin typeface="Segoe UI"/>
               </a:rPr>
-              <a:t>Sprint review - application mobile garage et API backend</a:t>
+              <a:t>Sprint </a:t>
+            </a:r>
+            <a:r>
+              <a:rPr lang="fr-CA" sz="1100" b="0" dirty="0">
+                <a:solidFill>
+                  <a:srgbClr val="475569"/>
+                </a:solidFill>
+                <a:latin typeface="Segoe UI"/>
+              </a:rPr>
+              <a:t>5</a:t>
+            </a:r>
+            <a:r>
+              <a:rPr sz="1100" b="0" dirty="0">
+                <a:solidFill>
+                  <a:srgbClr val="475569"/>
+                </a:solidFill>
+                <a:latin typeface="Segoe UI"/>
+              </a:rPr>
+              <a:t> - application mobile garage et API backend</a:t>
             </a:r>
           </a:p>
         </p:txBody>
@@ -7215,19 +7640,34 @@
           </a:fontRef>
         </p:style>
         <p:txBody>
-          <a:bodyPr rtlCol="0" anchor="ctr" lIns="182880" rIns="137160" tIns="137160" bIns="91440"/>
+          <a:bodyPr lIns="182880" tIns="137160" rIns="137160" bIns="91440" rtlCol="0" anchor="ctr"/>
           <a:lstStyle/>
           <a:p>
             <a:pPr algn="ctr"/>
             <a:r>
-              <a:rPr sz="1800" b="1">
+              <a:rPr sz="1800" b="1" dirty="0">
                 <a:solidFill>
                   <a:srgbClr val="171F2C"/>
                 </a:solidFill>
                 <a:latin typeface="Segoe UI"/>
               </a:rPr>
-              <a:t>Points cles</a:t>
-            </a:r>
+              <a:t>Points </a:t>
+            </a:r>
+            <a:r>
+              <a:rPr sz="1800" b="1" dirty="0" err="1">
+                <a:solidFill>
+                  <a:srgbClr val="171F2C"/>
+                </a:solidFill>
+                <a:latin typeface="Segoe UI"/>
+              </a:rPr>
+              <a:t>cles</a:t>
+            </a:r>
+            <a:endParaRPr sz="1800" b="1" dirty="0">
+              <a:solidFill>
+                <a:srgbClr val="171F2C"/>
+              </a:solidFill>
+              <a:latin typeface="Segoe UI"/>
+            </a:endParaRPr>
           </a:p>
           <a:p>
             <a:pPr>
@@ -7242,7 +7682,48 @@
               </a:defRPr>
             </a:pPr>
             <a:r>
-              <a:t>- Le client modifie ses coordonnees et preferences depuis Mes informations.</a:t>
+              <a:rPr dirty="0"/>
+              <a:t>- Le client </a:t>
+            </a:r>
+            <a:r>
+              <a:rPr dirty="0" err="1"/>
+              <a:t>modifie</a:t>
+            </a:r>
+            <a:r>
+              <a:rPr dirty="0"/>
+              <a:t> </a:t>
+            </a:r>
+            <a:r>
+              <a:rPr dirty="0" err="1"/>
+              <a:t>ses</a:t>
+            </a:r>
+            <a:r>
+              <a:rPr dirty="0"/>
+              <a:t> </a:t>
+            </a:r>
+            <a:r>
+              <a:rPr dirty="0" err="1"/>
+              <a:t>coordonnees</a:t>
+            </a:r>
+            <a:r>
+              <a:rPr dirty="0"/>
+              <a:t> et preferences </a:t>
+            </a:r>
+            <a:r>
+              <a:rPr dirty="0" err="1"/>
+              <a:t>depuis</a:t>
+            </a:r>
+            <a:r>
+              <a:rPr dirty="0"/>
+              <a:t> Mes </a:t>
+            </a:r>
+            <a:r>
+              <a:rPr dirty="0" err="1"/>
+              <a:t>informations</a:t>
+            </a:r>
+            <a:r>
+              <a:rPr dirty="0"/>
+              <a:t>.</a:t>
             </a:r>
           </a:p>
           <a:p>
@@ -7258,7 +7739,40 @@
               </a:defRPr>
             </a:pPr>
             <a:r>
-              <a:t>- Le payload est normalise cote frontend puis envoye a PUT /api/profile.</a:t>
+              <a:rPr dirty="0"/>
+              <a:t>- Le payload est </a:t>
+            </a:r>
+            <a:r>
+              <a:rPr dirty="0" err="1"/>
+              <a:t>normalise</a:t>
+            </a:r>
+            <a:r>
+              <a:rPr dirty="0"/>
+              <a:t> cote frontend </a:t>
+            </a:r>
+            <a:r>
+              <a:rPr dirty="0" err="1"/>
+              <a:t>puis</a:t>
+            </a:r>
+            <a:r>
+              <a:rPr dirty="0"/>
+              <a:t> </a:t>
+            </a:r>
+            <a:r>
+              <a:rPr dirty="0" err="1"/>
+              <a:t>envoye</a:t>
+            </a:r>
+            <a:r>
+              <a:rPr dirty="0"/>
+              <a:t> a PUT /</a:t>
+            </a:r>
+            <a:r>
+              <a:rPr dirty="0" err="1"/>
+              <a:t>api</a:t>
+            </a:r>
+            <a:r>
+              <a:rPr dirty="0"/>
+              <a:t>/profile.</a:t>
             </a:r>
           </a:p>
           <a:p>
@@ -7274,7 +7788,48 @@
               </a:defRPr>
             </a:pPr>
             <a:r>
-              <a:t>- La session reste coherente meme apres changement d'email.</a:t>
+              <a:rPr dirty="0"/>
+              <a:t>- La session </a:t>
+            </a:r>
+            <a:r>
+              <a:rPr dirty="0" err="1"/>
+              <a:t>reste</a:t>
+            </a:r>
+            <a:r>
+              <a:rPr dirty="0"/>
+              <a:t> </a:t>
+            </a:r>
+            <a:r>
+              <a:rPr dirty="0" err="1"/>
+              <a:t>coherente</a:t>
+            </a:r>
+            <a:r>
+              <a:rPr dirty="0"/>
+              <a:t> meme </a:t>
+            </a:r>
+            <a:r>
+              <a:rPr dirty="0" err="1"/>
+              <a:t>apres</a:t>
+            </a:r>
+            <a:r>
+              <a:rPr dirty="0"/>
+              <a:t> </a:t>
+            </a:r>
+            <a:r>
+              <a:rPr dirty="0" err="1"/>
+              <a:t>changement</a:t>
+            </a:r>
+            <a:r>
+              <a:rPr dirty="0"/>
+              <a:t> </a:t>
+            </a:r>
+            <a:r>
+              <a:rPr dirty="0" err="1"/>
+              <a:t>d'email</a:t>
+            </a:r>
+            <a:r>
+              <a:rPr dirty="0"/>
+              <a:t>.</a:t>
             </a:r>
           </a:p>
         </p:txBody>
@@ -7371,7 +7926,7 @@
 </file>
 
 <file path=ppt/slides/slide9.xml><?xml version="1.0" encoding="utf-8"?>
-<p:sld xmlns:a="http://schemas.openxmlformats.org/drawingml/2006/main" xmlns:p="http://schemas.openxmlformats.org/presentationml/2006/main" xmlns:r="http://schemas.openxmlformats.org/officeDocument/2006/relationships">
+<p:sld xmlns:a="http://schemas.openxmlformats.org/drawingml/2006/main" xmlns:r="http://schemas.openxmlformats.org/officeDocument/2006/relationships" xmlns:p="http://schemas.openxmlformats.org/presentationml/2006/main">
   <p:cSld>
     <p:bg>
       <p:bgPr>
@@ -7387,7 +7942,14 @@
         <p:cNvGrpSpPr/>
         <p:nvPr/>
       </p:nvGrpSpPr>
-      <p:grpSpPr/>
+      <p:grpSpPr>
+        <a:xfrm>
+          <a:off x="0" y="0"/>
+          <a:ext cx="0" cy="0"/>
+          <a:chOff x="0" y="0"/>
+          <a:chExt cx="0" cy="0"/>
+        </a:xfrm>
+      </p:grpSpPr>
       <p:sp>
         <p:nvSpPr>
           <p:cNvPr id="2" name="Rounded Rectangle 1"/>
@@ -7536,7 +8098,7 @@
         <p:spPr>
           <a:xfrm>
             <a:off x="530352" y="932688"/>
-            <a:ext cx="10881360" cy="256032"/>
+            <a:ext cx="3405099" cy="261610"/>
           </a:xfrm>
           <a:prstGeom prst="rect">
             <a:avLst/>
@@ -7551,13 +8113,31 @@
           <a:p>
             <a:pPr algn="l"/>
             <a:r>
-              <a:rPr sz="1100" b="0">
+              <a:rPr sz="1100" b="0" dirty="0">
                 <a:solidFill>
                   <a:srgbClr val="475569"/>
                 </a:solidFill>
                 <a:latin typeface="Segoe UI"/>
               </a:rPr>
-              <a:t>Sprint review - application mobile garage et API backend</a:t>
+              <a:t>Sprint </a:t>
+            </a:r>
+            <a:r>
+              <a:rPr lang="fr-CA" sz="1100" b="0" dirty="0">
+                <a:solidFill>
+                  <a:srgbClr val="475569"/>
+                </a:solidFill>
+                <a:latin typeface="Segoe UI"/>
+              </a:rPr>
+              <a:t>5</a:t>
+            </a:r>
+            <a:r>
+              <a:rPr sz="1100" b="0" dirty="0">
+                <a:solidFill>
+                  <a:srgbClr val="475569"/>
+                </a:solidFill>
+                <a:latin typeface="Segoe UI"/>
+              </a:rPr>
+              <a:t> - application mobile garage et API backend</a:t>
             </a:r>
           </a:p>
         </p:txBody>
@@ -7622,7 +8202,7 @@
           </a:fontRef>
         </p:style>
         <p:txBody>
-          <a:bodyPr rtlCol="0" anchor="ctr" lIns="182880" rIns="137160" tIns="137160" bIns="91440"/>
+          <a:bodyPr lIns="182880" tIns="137160" rIns="137160" bIns="91440" rtlCol="0" anchor="ctr"/>
           <a:lstStyle/>
           <a:p>
             <a:pPr algn="ctr"/>

</xml_diff>